<commit_message>
feat: add bonus experiments (multi-target 50m resolution & Mach 5 Doppler coupling with chirp diversity)
</commit_message>
<xml_diff>
--- a/PITCH_DECK.pptx
+++ b/PITCH_DECK.pptx
@@ -5539,7 +5539,7 @@
               </a:defRPr>
             </a:pPr>
             <a:r>
-              <a:t>Operational Insights, Trade-offs &amp; Conclusions</a:t>
+              <a:t>Insights, Bonus Experiments &amp; Conclusion</a:t>
             </a:r>
           </a:p>
         </p:txBody>
@@ -5597,8 +5597,8 @@
         </p:nvSpPr>
         <p:spPr>
           <a:xfrm>
-            <a:off x="914400" y="1645920"/>
-            <a:ext cx="4754880" cy="4389120"/>
+            <a:off x="914400" y="1554480"/>
+            <a:ext cx="4754880" cy="4572000"/>
           </a:xfrm>
           <a:prstGeom prst="rect">
             <a:avLst/>
@@ -5619,7 +5619,7 @@
               </a:defRPr>
             </a:pPr>
             <a:r>
-              <a:t>Operational Insights &amp; Engineering Trade-offs</a:t>
+              <a:t>Operational Insights &amp; Bonus Experiments</a:t>
             </a:r>
           </a:p>
           <a:p>
@@ -5634,7 +5634,7 @@
               </a:defRPr>
             </a:pPr>
             <a:r>
-              <a:t>• Rigorous +10 dB Proof: We mathematically, visually, and empirically verified that expanding pulse duration by 10x yields a +10.18 dB SNR boost while strictly maintaining identical ~35 m range resolution.</a:t>
+              <a:t>• Core Proof Verified: Matched-filter SNR increases by +10.18 dB (theory: +10.00 dB) while range resolution remains invariant at ~35 m for both 10 μs and 100 μs chirps.</a:t>
             </a:r>
           </a:p>
           <a:p>
@@ -5649,7 +5649,7 @@
               </a:defRPr>
             </a:pPr>
             <a:r>
-              <a:t>• Operational Impact: At 200 km, the 10 μs pulse provides only +4.25 dB link margin (vulnerable to rain fade or pointing loss). The 100 μs pulse provides an ironclad +14.25 dB margin.</a:t>
+              <a:t>• Operational Impact: At 200 km, the 100 μs pulse delivers +14.25 dB link margin and +16.99 dB CFAR margin, preventing target loss during rocket staging.</a:t>
             </a:r>
           </a:p>
           <a:p>
@@ -5664,7 +5664,7 @@
               </a:defRPr>
             </a:pPr>
             <a:r>
-              <a:t>• Blind Zone Limitation (Rmin = c·tau / 2): A 100 μs pulse blinds the radar up to 15.0 km (vs 1.5 km for 10 μs). Operational tracking radars solve this with dual-waveform scheduling.</a:t>
+              <a:t>• Bonus Exp 1 (Multi-Target at 200 km): Two targets separated by 50 m merge into a 15 km blob with unmodulated pulses, but are cleanly separated into 2 distinct peaks with LFM compression.</a:t>
             </a:r>
           </a:p>
           <a:p>
@@ -5679,14 +5679,14 @@
               </a:defRPr>
             </a:pPr>
             <a:r>
-              <a:t>• Doppler Coupling: For high-speed space targets, radial velocity shifts the peak by dt = -fd / kr. Alternating up/down chirps resolves this ambiguity.</a:t>
+              <a:t>• Bonus Exp 2 (Mach 5 Doppler Coupling): A 1500 m/s rocket induces -112.5 m range bias. We implemented Chirp Diversity (Up/Down chirp pairs), canceling the bias to -3 m and extracting exact velocity (1500 m/s)!</a:t>
             </a:r>
           </a:p>
         </p:txBody>
       </p:sp>
       <p:pic>
         <p:nvPicPr>
-          <p:cNvPr id="7" name="Picture 6" descr="fig5_detection_and_cfar_margin.png"/>
+          <p:cNvPr id="7" name="Picture 6" descr="fig6_multitarget_resolution.png"/>
           <p:cNvPicPr>
             <a:picLocks noChangeAspect="1"/>
           </p:cNvPicPr>

</xml_diff>

<commit_message>
Fix Track 1 deliverables and rebuild submission bundle
</commit_message>
<xml_diff>
--- a/PITCH_DECK.pptx
+++ b/PITCH_DECK.pptx
@@ -3264,7 +3264,11 @@
             <a:br/>
             <a:br/>
             <a:r>
-              <a:t>Team Name: Team Beyond Signals | Event: 24-Hour Research-Athon (Utkrishta 2026)</a:t>
+              <a:t>Team: Team Beyond Signals</a:t>
+            </a:r>
+            <a:br/>
+            <a:r>
+              <a:t>Members: Manas Vinod Jain, Vikhyat Gupta</a:t>
             </a:r>
           </a:p>
         </p:txBody>

</xml_diff>

<commit_message>
Fix radar validation and synchronize submission artifacts
</commit_message>
<xml_diff>
--- a/PITCH_DECK.pptx
+++ b/PITCH_DECK.pptx
@@ -3619,7 +3619,7 @@
               </a:defRPr>
             </a:pPr>
             <a:r>
-              <a:t>SDSC SHAR Radar Link Specifications</a:t>
+              <a:t>Assumed S-band Radar Link Specifications</a:t>
             </a:r>
           </a:p>
           <a:p>
@@ -5120,7 +5120,7 @@
                         </a:defRPr>
                       </a:pPr>
                       <a:r>
-                        <a:t>0.97x (Identical)</a:t>
+                        <a:t>Similar widths</a:t>
                       </a:r>
                     </a:p>
                   </a:txBody>
@@ -5356,7 +5356,7 @@
                         </a:defRPr>
                       </a:pPr>
                       <a:r>
-                        <a:t>+6.81 dB</a:t>
+                        <a:t>+4.14 dB</a:t>
                       </a:r>
                     </a:p>
                   </a:txBody>
@@ -5379,7 +5379,7 @@
                         </a:defRPr>
                       </a:pPr>
                       <a:r>
-                        <a:t>+16.99 dB</a:t>
+                        <a:t>+10.08 dB</a:t>
                       </a:r>
                     </a:p>
                   </a:txBody>
@@ -5402,7 +5402,7 @@
                         </a:defRPr>
                       </a:pPr>
                       <a:r>
-                        <a:t>+10.18 dB Boost</a:t>
+                        <a:t>+5.93 dB Boost</a:t>
                       </a:r>
                     </a:p>
                   </a:txBody>
@@ -5653,7 +5653,7 @@
               </a:defRPr>
             </a:pPr>
             <a:r>
-              <a:t>• Operational Impact: At 200 km, the 100 μs pulse delivers +14.25 dB link margin and +16.99 dB CFAR margin, preventing target loss during rocket staging.</a:t>
+              <a:t>• Validation: 200 production trials give mean 9.99 dB; 95% mean CI [9.88, 10.10] dB. Assumed link parameters; correlated MF cells limit nominal CFAR Pfa calibration.</a:t>
             </a:r>
           </a:p>
           <a:p>
@@ -5668,7 +5668,7 @@
               </a:defRPr>
             </a:pPr>
             <a:r>
-              <a:t>• Bonus Exp 1 (Multi-Target at 200 km): Two targets separated by 50 m merge into a 15 km blob with unmodulated pulses, but are cleanly separated into 2 distinct peaks with LFM compression.</a:t>
+              <a:t>• Bonus Exp 1 (Multi-Target at 200 km): The 50 m pair yields one local peak in this coherent unequal-target realization. Nominal c/(2B) resolution alone does not guarantee separation; phase, contrast and noise matter.</a:t>
             </a:r>
           </a:p>
           <a:p>

</xml_diff>